<commit_message>
Update lab and presentation of the second day
</commit_message>
<xml_diff>
--- a/presentaciones/BCI_Foundry_Dia3_L300_Produccion_Gobierno.pptx
+++ b/presentaciones/BCI_Foundry_Dia3_L300_Produccion_Gobierno.pptx
@@ -29648,7 +29648,7 @@
         </p:nvGraphicFramePr>
         <p:xfrm>
           <a:off x="548640" y="1508760"/>
-          <a:ext cx="11094415" cy="4206240"/>
+          <a:ext cx="11094415" cy="914400"/>
         </p:xfrm>
         <a:graphic>
           <a:graphicData uri="http://schemas.openxmlformats.org/drawingml/2006/table">
@@ -33666,7 +33666,7 @@
         </p:nvGraphicFramePr>
         <p:xfrm>
           <a:off x="548640" y="1508760"/>
-          <a:ext cx="11094416" cy="3886200"/>
+          <a:ext cx="11094415" cy="914400"/>
         </p:xfrm>
         <a:graphic>
           <a:graphicData uri="http://schemas.openxmlformats.org/drawingml/2006/table">
@@ -35908,7 +35908,7 @@
         </p:nvGraphicFramePr>
         <p:xfrm>
           <a:off x="548640" y="1508760"/>
-          <a:ext cx="11094416" cy="3886200"/>
+          <a:ext cx="11094415" cy="914400"/>
         </p:xfrm>
         <a:graphic>
           <a:graphicData uri="http://schemas.openxmlformats.org/drawingml/2006/table">

</xml_diff>